<commit_message>
Refresh app screenshots after risk-card recolour; propagate into deck / reports
Sample-profile buttons now only autofill the form (no auto-navigate), so
the capture script needed a second click on 'Predict risk levels' to
land on the Results page.  Fixed the capture, re-shot all 8 PNGs, and
regenerated the four downstream artefacts that embed them:

  deck/Review_Presentation.pptx                       (10-slide review)
  deck/*_WITH_RESULTS.pptx                            (64-slide full deck)
  docs/PROJECT_REPORT.docx                            (project write-up)
  docs/report.docx                                    (IIITDM template)

The Results screenshot now shows the recoloured level word (red 'High',
amber 'Medium', green 'Low') so reviewers see the same visual polish in
print as in the live app.
</commit_message>
<xml_diff>
--- a/deck/Review_Presentation.pptx
+++ b/deck/Review_Presentation.pptx
@@ -5,18 +5,18 @@
     <p:sldMasterId id="2147483648" r:id="rId1"/>
   </p:sldMasterIdLst>
   <p:sldIdLst>
-    <p:sldId id="256" r:id="rId2"/>
-    <p:sldId id="257" r:id="rId3"/>
-    <p:sldId id="258" r:id="rId4"/>
-    <p:sldId id="259" r:id="rId5"/>
-    <p:sldId id="260" r:id="rId6"/>
-    <p:sldId id="261" r:id="rId7"/>
-    <p:sldId id="262" r:id="rId8"/>
-    <p:sldId id="263" r:id="rId9"/>
-    <p:sldId id="264" r:id="rId10"/>
-    <p:sldId id="265" r:id="rId11"/>
+    <p:sldId id="256" r:id="rId7"/>
+    <p:sldId id="257" r:id="rId8"/>
+    <p:sldId id="258" r:id="rId9"/>
+    <p:sldId id="259" r:id="rId10"/>
+    <p:sldId id="260" r:id="rId11"/>
+    <p:sldId id="261" r:id="rId12"/>
+    <p:sldId id="262" r:id="rId13"/>
+    <p:sldId id="263" r:id="rId14"/>
+    <p:sldId id="264" r:id="rId15"/>
+    <p:sldId id="265" r:id="rId16"/>
   </p:sldIdLst>
-  <p:sldSz cx="12192000" cy="6858000"/>
+  <p:sldSz cx="12191695" cy="6858000" type="screen4x3"/>
   <p:notesSz cx="6858000" cy="9144000"/>
   <p:defaultTextStyle>
     <a:defPPr>
@@ -113,22 +113,6 @@
       </a:defRPr>
     </a:lvl9pPr>
   </p:defaultTextStyle>
-  <p:extLst>
-    <p:ext uri="{EFAFB233-063F-42B5-8137-9DF3F51BA10A}">
-      <p15:sldGuideLst xmlns:p15="http://schemas.microsoft.com/office/powerpoint/2012/main">
-        <p15:guide id="1" orient="horz" pos="2160">
-          <p15:clr>
-            <a:srgbClr val="A4A3A4"/>
-          </p15:clr>
-        </p15:guide>
-        <p15:guide id="2" pos="2880">
-          <p15:clr>
-            <a:srgbClr val="A4A3A4"/>
-          </p15:clr>
-        </p15:guide>
-      </p15:sldGuideLst>
-    </p:ext>
-  </p:extLst>
 </p:presentation>
 </file>
 
@@ -170,9 +154,10 @@
           <a:lstStyle/>
           <a:p>
             <a:r>
-              <a:rPr lang="en-US"/>
+              <a:rPr lang="en-US" smtClean="0"/>
               <a:t>Click to edit Master title style</a:t>
             </a:r>
+            <a:endParaRPr lang="en-US"/>
           </a:p>
         </p:txBody>
       </p:sp>
@@ -288,9 +273,10 @@
           </a:lstStyle>
           <a:p>
             <a:r>
-              <a:rPr lang="en-US"/>
+              <a:rPr lang="en-US" smtClean="0"/>
               <a:t>Click to edit Master subtitle style</a:t>
             </a:r>
+            <a:endParaRPr lang="en-US"/>
           </a:p>
         </p:txBody>
       </p:sp>
@@ -311,7 +297,7 @@
           <a:p>
             <a:fld id="{5BCAD085-E8A6-8845-BD4E-CB4CCA059FC4}" type="datetimeFigureOut">
               <a:rPr lang="en-US" smtClean="0"/>
-              <a:t>06-Jul-26</a:t>
+              <a:t>1/27/13</a:t>
             </a:fld>
             <a:endParaRPr lang="en-US"/>
           </a:p>
@@ -405,9 +391,10 @@
           <a:lstStyle/>
           <a:p>
             <a:r>
-              <a:rPr lang="en-US"/>
+              <a:rPr lang="en-US" smtClean="0"/>
               <a:t>Click to edit Master title style</a:t>
             </a:r>
+            <a:endParaRPr lang="en-US"/>
           </a:p>
         </p:txBody>
       </p:sp>
@@ -428,37 +415,38 @@
           <a:p>
             <a:pPr lvl="0"/>
             <a:r>
-              <a:rPr lang="en-US"/>
+              <a:rPr lang="en-US" smtClean="0"/>
               <a:t>Click to edit Master text styles</a:t>
             </a:r>
           </a:p>
           <a:p>
             <a:pPr lvl="1"/>
             <a:r>
-              <a:rPr lang="en-US"/>
+              <a:rPr lang="en-US" smtClean="0"/>
               <a:t>Second level</a:t>
             </a:r>
           </a:p>
           <a:p>
             <a:pPr lvl="2"/>
             <a:r>
-              <a:rPr lang="en-US"/>
+              <a:rPr lang="en-US" smtClean="0"/>
               <a:t>Third level</a:t>
             </a:r>
           </a:p>
           <a:p>
             <a:pPr lvl="3"/>
             <a:r>
-              <a:rPr lang="en-US"/>
+              <a:rPr lang="en-US" smtClean="0"/>
               <a:t>Fourth level</a:t>
             </a:r>
           </a:p>
           <a:p>
             <a:pPr lvl="4"/>
             <a:r>
-              <a:rPr lang="en-US"/>
+              <a:rPr lang="en-US" smtClean="0"/>
               <a:t>Fifth level</a:t>
             </a:r>
+            <a:endParaRPr lang="en-US"/>
           </a:p>
         </p:txBody>
       </p:sp>
@@ -479,7 +467,7 @@
           <a:p>
             <a:fld id="{5BCAD085-E8A6-8845-BD4E-CB4CCA059FC4}" type="datetimeFigureOut">
               <a:rPr lang="en-US" smtClean="0"/>
-              <a:t>06-Jul-26</a:t>
+              <a:t>1/27/13</a:t>
             </a:fld>
             <a:endParaRPr lang="en-US"/>
           </a:p>
@@ -578,9 +566,10 @@
           <a:lstStyle/>
           <a:p>
             <a:r>
-              <a:rPr lang="en-US"/>
+              <a:rPr lang="en-US" smtClean="0"/>
               <a:t>Click to edit Master title style</a:t>
             </a:r>
+            <a:endParaRPr lang="en-US"/>
           </a:p>
         </p:txBody>
       </p:sp>
@@ -606,37 +595,38 @@
           <a:p>
             <a:pPr lvl="0"/>
             <a:r>
-              <a:rPr lang="en-US"/>
+              <a:rPr lang="en-US" smtClean="0"/>
               <a:t>Click to edit Master text styles</a:t>
             </a:r>
           </a:p>
           <a:p>
             <a:pPr lvl="1"/>
             <a:r>
-              <a:rPr lang="en-US"/>
+              <a:rPr lang="en-US" smtClean="0"/>
               <a:t>Second level</a:t>
             </a:r>
           </a:p>
           <a:p>
             <a:pPr lvl="2"/>
             <a:r>
-              <a:rPr lang="en-US"/>
+              <a:rPr lang="en-US" smtClean="0"/>
               <a:t>Third level</a:t>
             </a:r>
           </a:p>
           <a:p>
             <a:pPr lvl="3"/>
             <a:r>
-              <a:rPr lang="en-US"/>
+              <a:rPr lang="en-US" smtClean="0"/>
               <a:t>Fourth level</a:t>
             </a:r>
           </a:p>
           <a:p>
             <a:pPr lvl="4"/>
             <a:r>
-              <a:rPr lang="en-US"/>
+              <a:rPr lang="en-US" smtClean="0"/>
               <a:t>Fifth level</a:t>
             </a:r>
+            <a:endParaRPr lang="en-US"/>
           </a:p>
         </p:txBody>
       </p:sp>
@@ -657,7 +647,7 @@
           <a:p>
             <a:fld id="{5BCAD085-E8A6-8845-BD4E-CB4CCA059FC4}" type="datetimeFigureOut">
               <a:rPr lang="en-US" smtClean="0"/>
-              <a:t>06-Jul-26</a:t>
+              <a:t>1/27/13</a:t>
             </a:fld>
             <a:endParaRPr lang="en-US"/>
           </a:p>
@@ -751,9 +741,10 @@
           <a:lstStyle/>
           <a:p>
             <a:r>
-              <a:rPr lang="en-US"/>
+              <a:rPr lang="en-US" smtClean="0"/>
               <a:t>Click to edit Master title style</a:t>
             </a:r>
+            <a:endParaRPr lang="en-US"/>
           </a:p>
         </p:txBody>
       </p:sp>
@@ -774,37 +765,38 @@
           <a:p>
             <a:pPr lvl="0"/>
             <a:r>
-              <a:rPr lang="en-US"/>
+              <a:rPr lang="en-US" smtClean="0"/>
               <a:t>Click to edit Master text styles</a:t>
             </a:r>
           </a:p>
           <a:p>
             <a:pPr lvl="1"/>
             <a:r>
-              <a:rPr lang="en-US"/>
+              <a:rPr lang="en-US" smtClean="0"/>
               <a:t>Second level</a:t>
             </a:r>
           </a:p>
           <a:p>
             <a:pPr lvl="2"/>
             <a:r>
-              <a:rPr lang="en-US"/>
+              <a:rPr lang="en-US" smtClean="0"/>
               <a:t>Third level</a:t>
             </a:r>
           </a:p>
           <a:p>
             <a:pPr lvl="3"/>
             <a:r>
-              <a:rPr lang="en-US"/>
+              <a:rPr lang="en-US" smtClean="0"/>
               <a:t>Fourth level</a:t>
             </a:r>
           </a:p>
           <a:p>
             <a:pPr lvl="4"/>
             <a:r>
-              <a:rPr lang="en-US"/>
+              <a:rPr lang="en-US" smtClean="0"/>
               <a:t>Fifth level</a:t>
             </a:r>
+            <a:endParaRPr lang="en-US"/>
           </a:p>
         </p:txBody>
       </p:sp>
@@ -825,7 +817,7 @@
           <a:p>
             <a:fld id="{5BCAD085-E8A6-8845-BD4E-CB4CCA059FC4}" type="datetimeFigureOut">
               <a:rPr lang="en-US" smtClean="0"/>
-              <a:t>06-Jul-26</a:t>
+              <a:t>1/27/13</a:t>
             </a:fld>
             <a:endParaRPr lang="en-US"/>
           </a:p>
@@ -928,9 +920,10 @@
           </a:lstStyle>
           <a:p>
             <a:r>
-              <a:rPr lang="en-US"/>
+              <a:rPr lang="en-US" smtClean="0"/>
               <a:t>Click to edit Master title style</a:t>
             </a:r>
+            <a:endParaRPr lang="en-US"/>
           </a:p>
         </p:txBody>
       </p:sp>
@@ -1047,7 +1040,7 @@
           <a:p>
             <a:pPr lvl="0"/>
             <a:r>
-              <a:rPr lang="en-US"/>
+              <a:rPr lang="en-US" smtClean="0"/>
               <a:t>Click to edit Master text styles</a:t>
             </a:r>
           </a:p>
@@ -1070,7 +1063,7 @@
           <a:p>
             <a:fld id="{5BCAD085-E8A6-8845-BD4E-CB4CCA059FC4}" type="datetimeFigureOut">
               <a:rPr lang="en-US" smtClean="0"/>
-              <a:t>06-Jul-26</a:t>
+              <a:t>1/27/13</a:t>
             </a:fld>
             <a:endParaRPr lang="en-US"/>
           </a:p>
@@ -1164,9 +1157,10 @@
           <a:lstStyle/>
           <a:p>
             <a:r>
-              <a:rPr lang="en-US"/>
+              <a:rPr lang="en-US" smtClean="0"/>
               <a:t>Click to edit Master title style</a:t>
             </a:r>
+            <a:endParaRPr lang="en-US"/>
           </a:p>
         </p:txBody>
       </p:sp>
@@ -1220,37 +1214,38 @@
           <a:p>
             <a:pPr lvl="0"/>
             <a:r>
-              <a:rPr lang="en-US"/>
+              <a:rPr lang="en-US" smtClean="0"/>
               <a:t>Click to edit Master text styles</a:t>
             </a:r>
           </a:p>
           <a:p>
             <a:pPr lvl="1"/>
             <a:r>
-              <a:rPr lang="en-US"/>
+              <a:rPr lang="en-US" smtClean="0"/>
               <a:t>Second level</a:t>
             </a:r>
           </a:p>
           <a:p>
             <a:pPr lvl="2"/>
             <a:r>
-              <a:rPr lang="en-US"/>
+              <a:rPr lang="en-US" smtClean="0"/>
               <a:t>Third level</a:t>
             </a:r>
           </a:p>
           <a:p>
             <a:pPr lvl="3"/>
             <a:r>
-              <a:rPr lang="en-US"/>
+              <a:rPr lang="en-US" smtClean="0"/>
               <a:t>Fourth level</a:t>
             </a:r>
           </a:p>
           <a:p>
             <a:pPr lvl="4"/>
             <a:r>
-              <a:rPr lang="en-US"/>
+              <a:rPr lang="en-US" smtClean="0"/>
               <a:t>Fifth level</a:t>
             </a:r>
+            <a:endParaRPr lang="en-US"/>
           </a:p>
         </p:txBody>
       </p:sp>
@@ -1304,37 +1299,38 @@
           <a:p>
             <a:pPr lvl="0"/>
             <a:r>
-              <a:rPr lang="en-US"/>
+              <a:rPr lang="en-US" smtClean="0"/>
               <a:t>Click to edit Master text styles</a:t>
             </a:r>
           </a:p>
           <a:p>
             <a:pPr lvl="1"/>
             <a:r>
-              <a:rPr lang="en-US"/>
+              <a:rPr lang="en-US" smtClean="0"/>
               <a:t>Second level</a:t>
             </a:r>
           </a:p>
           <a:p>
             <a:pPr lvl="2"/>
             <a:r>
-              <a:rPr lang="en-US"/>
+              <a:rPr lang="en-US" smtClean="0"/>
               <a:t>Third level</a:t>
             </a:r>
           </a:p>
           <a:p>
             <a:pPr lvl="3"/>
             <a:r>
-              <a:rPr lang="en-US"/>
+              <a:rPr lang="en-US" smtClean="0"/>
               <a:t>Fourth level</a:t>
             </a:r>
           </a:p>
           <a:p>
             <a:pPr lvl="4"/>
             <a:r>
-              <a:rPr lang="en-US"/>
+              <a:rPr lang="en-US" smtClean="0"/>
               <a:t>Fifth level</a:t>
             </a:r>
+            <a:endParaRPr lang="en-US"/>
           </a:p>
         </p:txBody>
       </p:sp>
@@ -1355,7 +1351,7 @@
           <a:p>
             <a:fld id="{5BCAD085-E8A6-8845-BD4E-CB4CCA059FC4}" type="datetimeFigureOut">
               <a:rPr lang="en-US" smtClean="0"/>
-              <a:t>06-Jul-26</a:t>
+              <a:t>1/27/13</a:t>
             </a:fld>
             <a:endParaRPr lang="en-US"/>
           </a:p>
@@ -1453,9 +1449,10 @@
           </a:lstStyle>
           <a:p>
             <a:r>
-              <a:rPr lang="en-US"/>
+              <a:rPr lang="en-US" smtClean="0"/>
               <a:t>Click to edit Master title style</a:t>
             </a:r>
+            <a:endParaRPr lang="en-US"/>
           </a:p>
         </p:txBody>
       </p:sp>
@@ -1518,7 +1515,7 @@
           <a:p>
             <a:pPr lvl="0"/>
             <a:r>
-              <a:rPr lang="en-US"/>
+              <a:rPr lang="en-US" smtClean="0"/>
               <a:t>Click to edit Master text styles</a:t>
             </a:r>
           </a:p>
@@ -1574,37 +1571,38 @@
           <a:p>
             <a:pPr lvl="0"/>
             <a:r>
-              <a:rPr lang="en-US"/>
+              <a:rPr lang="en-US" smtClean="0"/>
               <a:t>Click to edit Master text styles</a:t>
             </a:r>
           </a:p>
           <a:p>
             <a:pPr lvl="1"/>
             <a:r>
-              <a:rPr lang="en-US"/>
+              <a:rPr lang="en-US" smtClean="0"/>
               <a:t>Second level</a:t>
             </a:r>
           </a:p>
           <a:p>
             <a:pPr lvl="2"/>
             <a:r>
-              <a:rPr lang="en-US"/>
+              <a:rPr lang="en-US" smtClean="0"/>
               <a:t>Third level</a:t>
             </a:r>
           </a:p>
           <a:p>
             <a:pPr lvl="3"/>
             <a:r>
-              <a:rPr lang="en-US"/>
+              <a:rPr lang="en-US" smtClean="0"/>
               <a:t>Fourth level</a:t>
             </a:r>
           </a:p>
           <a:p>
             <a:pPr lvl="4"/>
             <a:r>
-              <a:rPr lang="en-US"/>
+              <a:rPr lang="en-US" smtClean="0"/>
               <a:t>Fifth level</a:t>
             </a:r>
+            <a:endParaRPr lang="en-US"/>
           </a:p>
         </p:txBody>
       </p:sp>
@@ -1667,7 +1665,7 @@
           <a:p>
             <a:pPr lvl="0"/>
             <a:r>
-              <a:rPr lang="en-US"/>
+              <a:rPr lang="en-US" smtClean="0"/>
               <a:t>Click to edit Master text styles</a:t>
             </a:r>
           </a:p>
@@ -1723,37 +1721,38 @@
           <a:p>
             <a:pPr lvl="0"/>
             <a:r>
-              <a:rPr lang="en-US"/>
+              <a:rPr lang="en-US" smtClean="0"/>
               <a:t>Click to edit Master text styles</a:t>
             </a:r>
           </a:p>
           <a:p>
             <a:pPr lvl="1"/>
             <a:r>
-              <a:rPr lang="en-US"/>
+              <a:rPr lang="en-US" smtClean="0"/>
               <a:t>Second level</a:t>
             </a:r>
           </a:p>
           <a:p>
             <a:pPr lvl="2"/>
             <a:r>
-              <a:rPr lang="en-US"/>
+              <a:rPr lang="en-US" smtClean="0"/>
               <a:t>Third level</a:t>
             </a:r>
           </a:p>
           <a:p>
             <a:pPr lvl="3"/>
             <a:r>
-              <a:rPr lang="en-US"/>
+              <a:rPr lang="en-US" smtClean="0"/>
               <a:t>Fourth level</a:t>
             </a:r>
           </a:p>
           <a:p>
             <a:pPr lvl="4"/>
             <a:r>
-              <a:rPr lang="en-US"/>
+              <a:rPr lang="en-US" smtClean="0"/>
               <a:t>Fifth level</a:t>
             </a:r>
+            <a:endParaRPr lang="en-US"/>
           </a:p>
         </p:txBody>
       </p:sp>
@@ -1774,7 +1773,7 @@
           <a:p>
             <a:fld id="{5BCAD085-E8A6-8845-BD4E-CB4CCA059FC4}" type="datetimeFigureOut">
               <a:rPr lang="en-US" smtClean="0"/>
-              <a:t>06-Jul-26</a:t>
+              <a:t>1/27/13</a:t>
             </a:fld>
             <a:endParaRPr lang="en-US"/>
           </a:p>
@@ -1868,9 +1867,10 @@
           <a:lstStyle/>
           <a:p>
             <a:r>
-              <a:rPr lang="en-US"/>
+              <a:rPr lang="en-US" smtClean="0"/>
               <a:t>Click to edit Master title style</a:t>
             </a:r>
+            <a:endParaRPr lang="en-US"/>
           </a:p>
         </p:txBody>
       </p:sp>
@@ -1891,7 +1891,7 @@
           <a:p>
             <a:fld id="{5BCAD085-E8A6-8845-BD4E-CB4CCA059FC4}" type="datetimeFigureOut">
               <a:rPr lang="en-US" smtClean="0"/>
-              <a:t>06-Jul-26</a:t>
+              <a:t>1/27/13</a:t>
             </a:fld>
             <a:endParaRPr lang="en-US"/>
           </a:p>
@@ -1986,7 +1986,7 @@
           <a:p>
             <a:fld id="{5BCAD085-E8A6-8845-BD4E-CB4CCA059FC4}" type="datetimeFigureOut">
               <a:rPr lang="en-US" smtClean="0"/>
-              <a:t>06-Jul-26</a:t>
+              <a:t>1/27/13</a:t>
             </a:fld>
             <a:endParaRPr lang="en-US"/>
           </a:p>
@@ -2089,9 +2089,10 @@
           </a:lstStyle>
           <a:p>
             <a:r>
-              <a:rPr lang="en-US"/>
+              <a:rPr lang="en-US" smtClean="0"/>
               <a:t>Click to edit Master title style</a:t>
             </a:r>
+            <a:endParaRPr lang="en-US"/>
           </a:p>
         </p:txBody>
       </p:sp>
@@ -2145,37 +2146,38 @@
           <a:p>
             <a:pPr lvl="0"/>
             <a:r>
-              <a:rPr lang="en-US"/>
+              <a:rPr lang="en-US" smtClean="0"/>
               <a:t>Click to edit Master text styles</a:t>
             </a:r>
           </a:p>
           <a:p>
             <a:pPr lvl="1"/>
             <a:r>
-              <a:rPr lang="en-US"/>
+              <a:rPr lang="en-US" smtClean="0"/>
               <a:t>Second level</a:t>
             </a:r>
           </a:p>
           <a:p>
             <a:pPr lvl="2"/>
             <a:r>
-              <a:rPr lang="en-US"/>
+              <a:rPr lang="en-US" smtClean="0"/>
               <a:t>Third level</a:t>
             </a:r>
           </a:p>
           <a:p>
             <a:pPr lvl="3"/>
             <a:r>
-              <a:rPr lang="en-US"/>
+              <a:rPr lang="en-US" smtClean="0"/>
               <a:t>Fourth level</a:t>
             </a:r>
           </a:p>
           <a:p>
             <a:pPr lvl="4"/>
             <a:r>
-              <a:rPr lang="en-US"/>
+              <a:rPr lang="en-US" smtClean="0"/>
               <a:t>Fifth level</a:t>
             </a:r>
+            <a:endParaRPr lang="en-US"/>
           </a:p>
         </p:txBody>
       </p:sp>
@@ -2238,7 +2240,7 @@
           <a:p>
             <a:pPr lvl="0"/>
             <a:r>
-              <a:rPr lang="en-US"/>
+              <a:rPr lang="en-US" smtClean="0"/>
               <a:t>Click to edit Master text styles</a:t>
             </a:r>
           </a:p>
@@ -2261,7 +2263,7 @@
           <a:p>
             <a:fld id="{5BCAD085-E8A6-8845-BD4E-CB4CCA059FC4}" type="datetimeFigureOut">
               <a:rPr lang="en-US" smtClean="0"/>
-              <a:t>06-Jul-26</a:t>
+              <a:t>1/27/13</a:t>
             </a:fld>
             <a:endParaRPr lang="en-US"/>
           </a:p>
@@ -2364,9 +2366,10 @@
           </a:lstStyle>
           <a:p>
             <a:r>
-              <a:rPr lang="en-US"/>
+              <a:rPr lang="en-US" smtClean="0"/>
               <a:t>Click to edit Master title style</a:t>
             </a:r>
+            <a:endParaRPr lang="en-US"/>
           </a:p>
         </p:txBody>
       </p:sp>
@@ -2490,7 +2493,7 @@
           <a:p>
             <a:pPr lvl="0"/>
             <a:r>
-              <a:rPr lang="en-US"/>
+              <a:rPr lang="en-US" smtClean="0"/>
               <a:t>Click to edit Master text styles</a:t>
             </a:r>
           </a:p>
@@ -2513,7 +2516,7 @@
           <a:p>
             <a:fld id="{5BCAD085-E8A6-8845-BD4E-CB4CCA059FC4}" type="datetimeFigureOut">
               <a:rPr lang="en-US" smtClean="0"/>
-              <a:t>06-Jul-26</a:t>
+              <a:t>1/27/13</a:t>
             </a:fld>
             <a:endParaRPr lang="en-US"/>
           </a:p>
@@ -2622,9 +2625,10 @@
           <a:lstStyle/>
           <a:p>
             <a:r>
-              <a:rPr lang="en-US"/>
+              <a:rPr lang="en-US" smtClean="0"/>
               <a:t>Click to edit Master title style</a:t>
             </a:r>
+            <a:endParaRPr lang="en-US"/>
           </a:p>
         </p:txBody>
       </p:sp>
@@ -2655,37 +2659,38 @@
           <a:p>
             <a:pPr lvl="0"/>
             <a:r>
-              <a:rPr lang="en-US"/>
+              <a:rPr lang="en-US" smtClean="0"/>
               <a:t>Click to edit Master text styles</a:t>
             </a:r>
           </a:p>
           <a:p>
             <a:pPr lvl="1"/>
             <a:r>
-              <a:rPr lang="en-US"/>
+              <a:rPr lang="en-US" smtClean="0"/>
               <a:t>Second level</a:t>
             </a:r>
           </a:p>
           <a:p>
             <a:pPr lvl="2"/>
             <a:r>
-              <a:rPr lang="en-US"/>
+              <a:rPr lang="en-US" smtClean="0"/>
               <a:t>Third level</a:t>
             </a:r>
           </a:p>
           <a:p>
             <a:pPr lvl="3"/>
             <a:r>
-              <a:rPr lang="en-US"/>
+              <a:rPr lang="en-US" smtClean="0"/>
               <a:t>Fourth level</a:t>
             </a:r>
           </a:p>
           <a:p>
             <a:pPr lvl="4"/>
             <a:r>
-              <a:rPr lang="en-US"/>
+              <a:rPr lang="en-US" smtClean="0"/>
               <a:t>Fifth level</a:t>
             </a:r>
+            <a:endParaRPr lang="en-US"/>
           </a:p>
         </p:txBody>
       </p:sp>
@@ -2724,7 +2729,7 @@
           <a:p>
             <a:fld id="{5BCAD085-E8A6-8845-BD4E-CB4CCA059FC4}" type="datetimeFigureOut">
               <a:rPr lang="en-US" smtClean="0"/>
-              <a:t>06-Jul-26</a:t>
+              <a:t>1/27/13</a:t>
             </a:fld>
             <a:endParaRPr lang="en-US"/>
           </a:p>
@@ -3083,7 +3088,7 @@
 </file>
 
 <file path=ppt/slides/slide1.xml><?xml version="1.0" encoding="utf-8"?>
-<p:sld xmlns:a="http://schemas.openxmlformats.org/drawingml/2006/main" xmlns:r="http://schemas.openxmlformats.org/officeDocument/2006/relationships" xmlns:p="http://schemas.openxmlformats.org/presentationml/2006/main">
+<p:sld xmlns:a="http://schemas.openxmlformats.org/drawingml/2006/main" xmlns:p="http://schemas.openxmlformats.org/presentationml/2006/main" xmlns:r="http://schemas.openxmlformats.org/officeDocument/2006/relationships">
   <p:cSld>
     <p:spTree>
       <p:nvGrpSpPr>
@@ -3091,14 +3096,7 @@
         <p:cNvGrpSpPr/>
         <p:nvPr/>
       </p:nvGrpSpPr>
-      <p:grpSpPr>
-        <a:xfrm>
-          <a:off x="0" y="0"/>
-          <a:ext cx="0" cy="0"/>
-          <a:chOff x="0" y="0"/>
-          <a:chExt cx="0" cy="0"/>
-        </a:xfrm>
-      </p:grpSpPr>
+      <p:grpSpPr/>
       <p:sp>
         <p:nvSpPr>
           <p:cNvPr id="2" name="Rectangle 1"/>
@@ -3140,7 +3138,6 @@
           <a:lstStyle/>
           <a:p>
             <a:pPr algn="ctr"/>
-            <a:endParaRPr/>
           </a:p>
         </p:txBody>
       </p:sp>
@@ -3185,7 +3182,6 @@
           <a:lstStyle/>
           <a:p>
             <a:pPr algn="ctr"/>
-            <a:endParaRPr/>
           </a:p>
         </p:txBody>
       </p:sp>
@@ -3198,7 +3194,7 @@
         <p:spPr>
           <a:xfrm>
             <a:off x="640080" y="868680"/>
-            <a:ext cx="3456524" cy="276999"/>
+            <a:ext cx="10789920" cy="365760"/>
           </a:xfrm>
           <a:prstGeom prst="rect">
             <a:avLst/>
@@ -3218,7 +3214,7 @@
                 </a:solidFill>
                 <a:latin typeface="Calibri"/>
               </a:rPr>
-              <a:t>IIITDM-SIES INTERNSHIP  |  REVIEW PRESENTATION</a:t>
+              <a:t>IIITDM-SIES INTERNSHIP  |  MID-REVIEW PRESENTATION</a:t>
             </a:r>
           </a:p>
         </p:txBody>
@@ -3335,7 +3331,6 @@
           <a:lstStyle/>
           <a:p>
             <a:pPr algn="ctr"/>
-            <a:endParaRPr/>
           </a:p>
         </p:txBody>
       </p:sp>
@@ -3360,9 +3355,7 @@
             <a:spAutoFit/>
           </a:bodyPr>
           <a:lstStyle/>
-          <a:p>
-            <a:endParaRPr/>
-          </a:p>
+          <a:p/>
           <a:p>
             <a:pPr>
               <a:spcAft>
@@ -3508,7 +3501,7 @@
 </file>
 
 <file path=ppt/slides/slide10.xml><?xml version="1.0" encoding="utf-8"?>
-<p:sld xmlns:a="http://schemas.openxmlformats.org/drawingml/2006/main" xmlns:r="http://schemas.openxmlformats.org/officeDocument/2006/relationships" xmlns:p="http://schemas.openxmlformats.org/presentationml/2006/main">
+<p:sld xmlns:a="http://schemas.openxmlformats.org/drawingml/2006/main" xmlns:p="http://schemas.openxmlformats.org/presentationml/2006/main" xmlns:r="http://schemas.openxmlformats.org/officeDocument/2006/relationships">
   <p:cSld>
     <p:spTree>
       <p:nvGrpSpPr>
@@ -3516,14 +3509,7 @@
         <p:cNvGrpSpPr/>
         <p:nvPr/>
       </p:nvGrpSpPr>
-      <p:grpSpPr>
-        <a:xfrm>
-          <a:off x="0" y="0"/>
-          <a:ext cx="0" cy="0"/>
-          <a:chOff x="0" y="0"/>
-          <a:chExt cx="0" cy="0"/>
-        </a:xfrm>
-      </p:grpSpPr>
+      <p:grpSpPr/>
       <p:sp>
         <p:nvSpPr>
           <p:cNvPr id="2" name="Rectangle 1"/>
@@ -3565,7 +3551,6 @@
           <a:lstStyle/>
           <a:p>
             <a:pPr algn="ctr"/>
-            <a:endParaRPr/>
           </a:p>
         </p:txBody>
       </p:sp>
@@ -3610,7 +3595,6 @@
           <a:lstStyle/>
           <a:p>
             <a:pPr algn="ctr"/>
-            <a:endParaRPr/>
           </a:p>
         </p:txBody>
       </p:sp>
@@ -4066,7 +4050,6 @@
           <a:lstStyle/>
           <a:p>
             <a:pPr algn="ctr"/>
-            <a:endParaRPr/>
           </a:p>
         </p:txBody>
       </p:sp>
@@ -4183,7 +4166,7 @@
 </file>
 
 <file path=ppt/slides/slide2.xml><?xml version="1.0" encoding="utf-8"?>
-<p:sld xmlns:a="http://schemas.openxmlformats.org/drawingml/2006/main" xmlns:r="http://schemas.openxmlformats.org/officeDocument/2006/relationships" xmlns:p="http://schemas.openxmlformats.org/presentationml/2006/main">
+<p:sld xmlns:a="http://schemas.openxmlformats.org/drawingml/2006/main" xmlns:p="http://schemas.openxmlformats.org/presentationml/2006/main" xmlns:r="http://schemas.openxmlformats.org/officeDocument/2006/relationships">
   <p:cSld>
     <p:spTree>
       <p:nvGrpSpPr>
@@ -4191,14 +4174,7 @@
         <p:cNvGrpSpPr/>
         <p:nvPr/>
       </p:nvGrpSpPr>
-      <p:grpSpPr>
-        <a:xfrm>
-          <a:off x="0" y="0"/>
-          <a:ext cx="0" cy="0"/>
-          <a:chOff x="0" y="0"/>
-          <a:chExt cx="0" cy="0"/>
-        </a:xfrm>
-      </p:grpSpPr>
+      <p:grpSpPr/>
       <p:sp>
         <p:nvSpPr>
           <p:cNvPr id="2" name="Rectangle 1"/>
@@ -4240,7 +4216,6 @@
           <a:lstStyle/>
           <a:p>
             <a:pPr algn="ctr"/>
-            <a:endParaRPr/>
           </a:p>
         </p:txBody>
       </p:sp>
@@ -4285,7 +4260,6 @@
           <a:lstStyle/>
           <a:p>
             <a:pPr algn="ctr"/>
-            <a:endParaRPr/>
           </a:p>
         </p:txBody>
       </p:sp>
@@ -4593,7 +4567,7 @@
 </file>
 
 <file path=ppt/slides/slide3.xml><?xml version="1.0" encoding="utf-8"?>
-<p:sld xmlns:a="http://schemas.openxmlformats.org/drawingml/2006/main" xmlns:r="http://schemas.openxmlformats.org/officeDocument/2006/relationships" xmlns:p="http://schemas.openxmlformats.org/presentationml/2006/main">
+<p:sld xmlns:a="http://schemas.openxmlformats.org/drawingml/2006/main" xmlns:p="http://schemas.openxmlformats.org/presentationml/2006/main" xmlns:r="http://schemas.openxmlformats.org/officeDocument/2006/relationships">
   <p:cSld>
     <p:spTree>
       <p:nvGrpSpPr>
@@ -4601,14 +4575,7 @@
         <p:cNvGrpSpPr/>
         <p:nvPr/>
       </p:nvGrpSpPr>
-      <p:grpSpPr>
-        <a:xfrm>
-          <a:off x="0" y="0"/>
-          <a:ext cx="0" cy="0"/>
-          <a:chOff x="0" y="0"/>
-          <a:chExt cx="0" cy="0"/>
-        </a:xfrm>
-      </p:grpSpPr>
+      <p:grpSpPr/>
       <p:sp>
         <p:nvSpPr>
           <p:cNvPr id="2" name="Rectangle 1"/>
@@ -4650,7 +4617,6 @@
           <a:lstStyle/>
           <a:p>
             <a:pPr algn="ctr"/>
-            <a:endParaRPr/>
           </a:p>
         </p:txBody>
       </p:sp>
@@ -4695,7 +4661,6 @@
           <a:lstStyle/>
           <a:p>
             <a:pPr algn="ctr"/>
-            <a:endParaRPr/>
           </a:p>
         </p:txBody>
       </p:sp>
@@ -5042,7 +5007,7 @@
 </file>
 
 <file path=ppt/slides/slide4.xml><?xml version="1.0" encoding="utf-8"?>
-<p:sld xmlns:a="http://schemas.openxmlformats.org/drawingml/2006/main" xmlns:r="http://schemas.openxmlformats.org/officeDocument/2006/relationships" xmlns:p="http://schemas.openxmlformats.org/presentationml/2006/main">
+<p:sld xmlns:a="http://schemas.openxmlformats.org/drawingml/2006/main" xmlns:p="http://schemas.openxmlformats.org/presentationml/2006/main" xmlns:r="http://schemas.openxmlformats.org/officeDocument/2006/relationships">
   <p:cSld>
     <p:spTree>
       <p:nvGrpSpPr>
@@ -5050,14 +5015,7 @@
         <p:cNvGrpSpPr/>
         <p:nvPr/>
       </p:nvGrpSpPr>
-      <p:grpSpPr>
-        <a:xfrm>
-          <a:off x="0" y="0"/>
-          <a:ext cx="0" cy="0"/>
-          <a:chOff x="0" y="0"/>
-          <a:chExt cx="0" cy="0"/>
-        </a:xfrm>
-      </p:grpSpPr>
+      <p:grpSpPr/>
       <p:sp>
         <p:nvSpPr>
           <p:cNvPr id="2" name="Rectangle 1"/>
@@ -5099,7 +5057,6 @@
           <a:lstStyle/>
           <a:p>
             <a:pPr algn="ctr"/>
-            <a:endParaRPr/>
           </a:p>
         </p:txBody>
       </p:sp>
@@ -5144,7 +5101,6 @@
           <a:lstStyle/>
           <a:p>
             <a:pPr algn="ctr"/>
-            <a:endParaRPr/>
           </a:p>
         </p:txBody>
       </p:sp>
@@ -5259,7 +5215,6 @@
           <a:lstStyle/>
           <a:p>
             <a:pPr algn="ctr"/>
-            <a:endParaRPr/>
           </a:p>
         </p:txBody>
       </p:sp>
@@ -5599,7 +5554,6 @@
           <a:lstStyle/>
           <a:p>
             <a:pPr algn="ctr"/>
-            <a:endParaRPr/>
           </a:p>
         </p:txBody>
       </p:sp>
@@ -5939,7 +5893,7 @@
 </file>
 
 <file path=ppt/slides/slide5.xml><?xml version="1.0" encoding="utf-8"?>
-<p:sld xmlns:a="http://schemas.openxmlformats.org/drawingml/2006/main" xmlns:r="http://schemas.openxmlformats.org/officeDocument/2006/relationships" xmlns:p="http://schemas.openxmlformats.org/presentationml/2006/main">
+<p:sld xmlns:a="http://schemas.openxmlformats.org/drawingml/2006/main" xmlns:p="http://schemas.openxmlformats.org/presentationml/2006/main" xmlns:r="http://schemas.openxmlformats.org/officeDocument/2006/relationships">
   <p:cSld>
     <p:spTree>
       <p:nvGrpSpPr>
@@ -5947,14 +5901,7 @@
         <p:cNvGrpSpPr/>
         <p:nvPr/>
       </p:nvGrpSpPr>
-      <p:grpSpPr>
-        <a:xfrm>
-          <a:off x="0" y="0"/>
-          <a:ext cx="0" cy="0"/>
-          <a:chOff x="0" y="0"/>
-          <a:chExt cx="0" cy="0"/>
-        </a:xfrm>
-      </p:grpSpPr>
+      <p:grpSpPr/>
       <p:sp>
         <p:nvSpPr>
           <p:cNvPr id="2" name="Rectangle 1"/>
@@ -5996,7 +5943,6 @@
           <a:lstStyle/>
           <a:p>
             <a:pPr algn="ctr"/>
-            <a:endParaRPr/>
           </a:p>
         </p:txBody>
       </p:sp>
@@ -6041,7 +5987,6 @@
           <a:lstStyle/>
           <a:p>
             <a:pPr algn="ctr"/>
-            <a:endParaRPr/>
           </a:p>
         </p:txBody>
       </p:sp>
@@ -6132,48 +6077,12 @@
                 <a:tableStyleId>{5C22544A-7EE6-4342-B048-85BDC9FD1C3A}</a:tableStyleId>
               </a:tblPr>
               <a:tblGrid>
-                <a:gridCol w="1798320">
-                  <a:extLst>
-                    <a:ext uri="{9D8B030D-6E8A-4147-A177-3AD203B41FA5}">
-                      <a16:colId xmlns:a16="http://schemas.microsoft.com/office/drawing/2014/main" val="20000"/>
-                    </a:ext>
-                  </a:extLst>
-                </a:gridCol>
-                <a:gridCol w="1798320">
-                  <a:extLst>
-                    <a:ext uri="{9D8B030D-6E8A-4147-A177-3AD203B41FA5}">
-                      <a16:colId xmlns:a16="http://schemas.microsoft.com/office/drawing/2014/main" val="20001"/>
-                    </a:ext>
-                  </a:extLst>
-                </a:gridCol>
-                <a:gridCol w="1798320">
-                  <a:extLst>
-                    <a:ext uri="{9D8B030D-6E8A-4147-A177-3AD203B41FA5}">
-                      <a16:colId xmlns:a16="http://schemas.microsoft.com/office/drawing/2014/main" val="20002"/>
-                    </a:ext>
-                  </a:extLst>
-                </a:gridCol>
-                <a:gridCol w="1798320">
-                  <a:extLst>
-                    <a:ext uri="{9D8B030D-6E8A-4147-A177-3AD203B41FA5}">
-                      <a16:colId xmlns:a16="http://schemas.microsoft.com/office/drawing/2014/main" val="20003"/>
-                    </a:ext>
-                  </a:extLst>
-                </a:gridCol>
-                <a:gridCol w="1798320">
-                  <a:extLst>
-                    <a:ext uri="{9D8B030D-6E8A-4147-A177-3AD203B41FA5}">
-                      <a16:colId xmlns:a16="http://schemas.microsoft.com/office/drawing/2014/main" val="20004"/>
-                    </a:ext>
-                  </a:extLst>
-                </a:gridCol>
-                <a:gridCol w="1798320">
-                  <a:extLst>
-                    <a:ext uri="{9D8B030D-6E8A-4147-A177-3AD203B41FA5}">
-                      <a16:colId xmlns:a16="http://schemas.microsoft.com/office/drawing/2014/main" val="20005"/>
-                    </a:ext>
-                  </a:extLst>
-                </a:gridCol>
+                <a:gridCol w="1798320"/>
+                <a:gridCol w="1798320"/>
+                <a:gridCol w="1798320"/>
+                <a:gridCol w="1798320"/>
+                <a:gridCol w="1798320"/>
+                <a:gridCol w="1798320"/>
               </a:tblGrid>
               <a:tr h="457200">
                 <a:tc>
@@ -6314,11 +6223,6 @@
                     </a:solidFill>
                   </a:tcPr>
                 </a:tc>
-                <a:extLst>
-                  <a:ext uri="{0D108BD9-81ED-4DB2-BD59-A6C34878D82A}">
-                    <a16:rowId xmlns:a16="http://schemas.microsoft.com/office/drawing/2014/main" val="10000"/>
-                  </a:ext>
-                </a:extLst>
               </a:tr>
               <a:tr h="457200">
                 <a:tc>
@@ -6459,11 +6363,6 @@
                     </a:solidFill>
                   </a:tcPr>
                 </a:tc>
-                <a:extLst>
-                  <a:ext uri="{0D108BD9-81ED-4DB2-BD59-A6C34878D82A}">
-                    <a16:rowId xmlns:a16="http://schemas.microsoft.com/office/drawing/2014/main" val="10001"/>
-                  </a:ext>
-                </a:extLst>
               </a:tr>
               <a:tr h="457200">
                 <a:tc>
@@ -6604,11 +6503,6 @@
                     </a:solidFill>
                   </a:tcPr>
                 </a:tc>
-                <a:extLst>
-                  <a:ext uri="{0D108BD9-81ED-4DB2-BD59-A6C34878D82A}">
-                    <a16:rowId xmlns:a16="http://schemas.microsoft.com/office/drawing/2014/main" val="10002"/>
-                  </a:ext>
-                </a:extLst>
               </a:tr>
               <a:tr h="457200">
                 <a:tc>
@@ -6749,11 +6643,6 @@
                     </a:solidFill>
                   </a:tcPr>
                 </a:tc>
-                <a:extLst>
-                  <a:ext uri="{0D108BD9-81ED-4DB2-BD59-A6C34878D82A}">
-                    <a16:rowId xmlns:a16="http://schemas.microsoft.com/office/drawing/2014/main" val="10003"/>
-                  </a:ext>
-                </a:extLst>
               </a:tr>
               <a:tr h="457200">
                 <a:tc>
@@ -6894,11 +6783,6 @@
                     </a:solidFill>
                   </a:tcPr>
                 </a:tc>
-                <a:extLst>
-                  <a:ext uri="{0D108BD9-81ED-4DB2-BD59-A6C34878D82A}">
-                    <a16:rowId xmlns:a16="http://schemas.microsoft.com/office/drawing/2014/main" val="10004"/>
-                  </a:ext>
-                </a:extLst>
               </a:tr>
               <a:tr h="457200">
                 <a:tc>
@@ -7039,11 +6923,6 @@
                     </a:solidFill>
                   </a:tcPr>
                 </a:tc>
-                <a:extLst>
-                  <a:ext uri="{0D108BD9-81ED-4DB2-BD59-A6C34878D82A}">
-                    <a16:rowId xmlns:a16="http://schemas.microsoft.com/office/drawing/2014/main" val="10005"/>
-                  </a:ext>
-                </a:extLst>
               </a:tr>
               <a:tr h="457200">
                 <a:tc>
@@ -7184,11 +7063,6 @@
                     </a:solidFill>
                   </a:tcPr>
                 </a:tc>
-                <a:extLst>
-                  <a:ext uri="{0D108BD9-81ED-4DB2-BD59-A6C34878D82A}">
-                    <a16:rowId xmlns:a16="http://schemas.microsoft.com/office/drawing/2014/main" val="10006"/>
-                  </a:ext>
-                </a:extLst>
               </a:tr>
             </a:tbl>
           </a:graphicData>
@@ -7272,7 +7146,7 @@
 </file>
 
 <file path=ppt/slides/slide6.xml><?xml version="1.0" encoding="utf-8"?>
-<p:sld xmlns:a="http://schemas.openxmlformats.org/drawingml/2006/main" xmlns:r="http://schemas.openxmlformats.org/officeDocument/2006/relationships" xmlns:p="http://schemas.openxmlformats.org/presentationml/2006/main">
+<p:sld xmlns:a="http://schemas.openxmlformats.org/drawingml/2006/main" xmlns:p="http://schemas.openxmlformats.org/presentationml/2006/main" xmlns:r="http://schemas.openxmlformats.org/officeDocument/2006/relationships">
   <p:cSld>
     <p:spTree>
       <p:nvGrpSpPr>
@@ -7280,14 +7154,7 @@
         <p:cNvGrpSpPr/>
         <p:nvPr/>
       </p:nvGrpSpPr>
-      <p:grpSpPr>
-        <a:xfrm>
-          <a:off x="0" y="0"/>
-          <a:ext cx="0" cy="0"/>
-          <a:chOff x="0" y="0"/>
-          <a:chExt cx="0" cy="0"/>
-        </a:xfrm>
-      </p:grpSpPr>
+      <p:grpSpPr/>
       <p:sp>
         <p:nvSpPr>
           <p:cNvPr id="2" name="Rectangle 1"/>
@@ -7329,7 +7196,6 @@
           <a:lstStyle/>
           <a:p>
             <a:pPr algn="ctr"/>
-            <a:endParaRPr/>
           </a:p>
         </p:txBody>
       </p:sp>
@@ -7374,7 +7240,6 @@
           <a:lstStyle/>
           <a:p>
             <a:pPr algn="ctr"/>
-            <a:endParaRPr/>
           </a:p>
         </p:txBody>
       </p:sp>
@@ -7816,27 +7681,9 @@
                 <a:tableStyleId>{5C22544A-7EE6-4342-B048-85BDC9FD1C3A}</a:tableStyleId>
               </a:tblPr>
               <a:tblGrid>
-                <a:gridCol w="1645920">
-                  <a:extLst>
-                    <a:ext uri="{9D8B030D-6E8A-4147-A177-3AD203B41FA5}">
-                      <a16:colId xmlns:a16="http://schemas.microsoft.com/office/drawing/2014/main" val="20000"/>
-                    </a:ext>
-                  </a:extLst>
-                </a:gridCol>
-                <a:gridCol w="1645920">
-                  <a:extLst>
-                    <a:ext uri="{9D8B030D-6E8A-4147-A177-3AD203B41FA5}">
-                      <a16:colId xmlns:a16="http://schemas.microsoft.com/office/drawing/2014/main" val="20001"/>
-                    </a:ext>
-                  </a:extLst>
-                </a:gridCol>
-                <a:gridCol w="1645920">
-                  <a:extLst>
-                    <a:ext uri="{9D8B030D-6E8A-4147-A177-3AD203B41FA5}">
-                      <a16:colId xmlns:a16="http://schemas.microsoft.com/office/drawing/2014/main" val="20002"/>
-                    </a:ext>
-                  </a:extLst>
-                </a:gridCol>
+                <a:gridCol w="1645920"/>
+                <a:gridCol w="1645920"/>
+                <a:gridCol w="1645920"/>
               </a:tblGrid>
               <a:tr h="391885">
                 <a:tc>
@@ -7908,11 +7755,6 @@
                     </a:solidFill>
                   </a:tcPr>
                 </a:tc>
-                <a:extLst>
-                  <a:ext uri="{0D108BD9-81ED-4DB2-BD59-A6C34878D82A}">
-                    <a16:rowId xmlns:a16="http://schemas.microsoft.com/office/drawing/2014/main" val="10000"/>
-                  </a:ext>
-                </a:extLst>
               </a:tr>
               <a:tr h="391885">
                 <a:tc>
@@ -7984,11 +7826,6 @@
                     </a:solidFill>
                   </a:tcPr>
                 </a:tc>
-                <a:extLst>
-                  <a:ext uri="{0D108BD9-81ED-4DB2-BD59-A6C34878D82A}">
-                    <a16:rowId xmlns:a16="http://schemas.microsoft.com/office/drawing/2014/main" val="10001"/>
-                  </a:ext>
-                </a:extLst>
               </a:tr>
               <a:tr h="391885">
                 <a:tc>
@@ -8060,11 +7897,6 @@
                     </a:solidFill>
                   </a:tcPr>
                 </a:tc>
-                <a:extLst>
-                  <a:ext uri="{0D108BD9-81ED-4DB2-BD59-A6C34878D82A}">
-                    <a16:rowId xmlns:a16="http://schemas.microsoft.com/office/drawing/2014/main" val="10002"/>
-                  </a:ext>
-                </a:extLst>
               </a:tr>
               <a:tr h="391885">
                 <a:tc>
@@ -8136,11 +7968,6 @@
                     </a:solidFill>
                   </a:tcPr>
                 </a:tc>
-                <a:extLst>
-                  <a:ext uri="{0D108BD9-81ED-4DB2-BD59-A6C34878D82A}">
-                    <a16:rowId xmlns:a16="http://schemas.microsoft.com/office/drawing/2014/main" val="10003"/>
-                  </a:ext>
-                </a:extLst>
               </a:tr>
               <a:tr h="391885">
                 <a:tc>
@@ -8212,11 +8039,6 @@
                     </a:solidFill>
                   </a:tcPr>
                 </a:tc>
-                <a:extLst>
-                  <a:ext uri="{0D108BD9-81ED-4DB2-BD59-A6C34878D82A}">
-                    <a16:rowId xmlns:a16="http://schemas.microsoft.com/office/drawing/2014/main" val="10004"/>
-                  </a:ext>
-                </a:extLst>
               </a:tr>
               <a:tr h="391885">
                 <a:tc>
@@ -8288,11 +8110,6 @@
                     </a:solidFill>
                   </a:tcPr>
                 </a:tc>
-                <a:extLst>
-                  <a:ext uri="{0D108BD9-81ED-4DB2-BD59-A6C34878D82A}">
-                    <a16:rowId xmlns:a16="http://schemas.microsoft.com/office/drawing/2014/main" val="10005"/>
-                  </a:ext>
-                </a:extLst>
               </a:tr>
               <a:tr h="391890">
                 <a:tc>
@@ -8364,11 +8181,6 @@
                     </a:solidFill>
                   </a:tcPr>
                 </a:tc>
-                <a:extLst>
-                  <a:ext uri="{0D108BD9-81ED-4DB2-BD59-A6C34878D82A}">
-                    <a16:rowId xmlns:a16="http://schemas.microsoft.com/office/drawing/2014/main" val="10006"/>
-                  </a:ext>
-                </a:extLst>
               </a:tr>
             </a:tbl>
           </a:graphicData>
@@ -8452,7 +8264,7 @@
 </file>
 
 <file path=ppt/slides/slide7.xml><?xml version="1.0" encoding="utf-8"?>
-<p:sld xmlns:a="http://schemas.openxmlformats.org/drawingml/2006/main" xmlns:r="http://schemas.openxmlformats.org/officeDocument/2006/relationships" xmlns:p="http://schemas.openxmlformats.org/presentationml/2006/main">
+<p:sld xmlns:a="http://schemas.openxmlformats.org/drawingml/2006/main" xmlns:p="http://schemas.openxmlformats.org/presentationml/2006/main" xmlns:r="http://schemas.openxmlformats.org/officeDocument/2006/relationships">
   <p:cSld>
     <p:spTree>
       <p:nvGrpSpPr>
@@ -8460,14 +8272,7 @@
         <p:cNvGrpSpPr/>
         <p:nvPr/>
       </p:nvGrpSpPr>
-      <p:grpSpPr>
-        <a:xfrm>
-          <a:off x="0" y="0"/>
-          <a:ext cx="0" cy="0"/>
-          <a:chOff x="0" y="0"/>
-          <a:chExt cx="0" cy="0"/>
-        </a:xfrm>
-      </p:grpSpPr>
+      <p:grpSpPr/>
       <p:sp>
         <p:nvSpPr>
           <p:cNvPr id="2" name="Rectangle 1"/>
@@ -8509,7 +8314,6 @@
           <a:lstStyle/>
           <a:p>
             <a:pPr algn="ctr"/>
-            <a:endParaRPr/>
           </a:p>
         </p:txBody>
       </p:sp>
@@ -8554,7 +8358,6 @@
           <a:lstStyle/>
           <a:p>
             <a:pPr algn="ctr"/>
-            <a:endParaRPr/>
           </a:p>
         </p:txBody>
       </p:sp>
@@ -8739,34 +8542,10 @@
                 <a:tableStyleId>{5C22544A-7EE6-4342-B048-85BDC9FD1C3A}</a:tableStyleId>
               </a:tblPr>
               <a:tblGrid>
-                <a:gridCol w="1325880">
-                  <a:extLst>
-                    <a:ext uri="{9D8B030D-6E8A-4147-A177-3AD203B41FA5}">
-                      <a16:colId xmlns:a16="http://schemas.microsoft.com/office/drawing/2014/main" val="20000"/>
-                    </a:ext>
-                  </a:extLst>
-                </a:gridCol>
-                <a:gridCol w="1325880">
-                  <a:extLst>
-                    <a:ext uri="{9D8B030D-6E8A-4147-A177-3AD203B41FA5}">
-                      <a16:colId xmlns:a16="http://schemas.microsoft.com/office/drawing/2014/main" val="20001"/>
-                    </a:ext>
-                  </a:extLst>
-                </a:gridCol>
-                <a:gridCol w="1325880">
-                  <a:extLst>
-                    <a:ext uri="{9D8B030D-6E8A-4147-A177-3AD203B41FA5}">
-                      <a16:colId xmlns:a16="http://schemas.microsoft.com/office/drawing/2014/main" val="20002"/>
-                    </a:ext>
-                  </a:extLst>
-                </a:gridCol>
-                <a:gridCol w="1325880">
-                  <a:extLst>
-                    <a:ext uri="{9D8B030D-6E8A-4147-A177-3AD203B41FA5}">
-                      <a16:colId xmlns:a16="http://schemas.microsoft.com/office/drawing/2014/main" val="20003"/>
-                    </a:ext>
-                  </a:extLst>
-                </a:gridCol>
+                <a:gridCol w="1325880"/>
+                <a:gridCol w="1325880"/>
+                <a:gridCol w="1325880"/>
+                <a:gridCol w="1325880"/>
               </a:tblGrid>
               <a:tr h="261257">
                 <a:tc>
@@ -8861,11 +8640,6 @@
                     </a:solidFill>
                   </a:tcPr>
                 </a:tc>
-                <a:extLst>
-                  <a:ext uri="{0D108BD9-81ED-4DB2-BD59-A6C34878D82A}">
-                    <a16:rowId xmlns:a16="http://schemas.microsoft.com/office/drawing/2014/main" val="10000"/>
-                  </a:ext>
-                </a:extLst>
               </a:tr>
               <a:tr h="261257">
                 <a:tc>
@@ -8960,11 +8734,6 @@
                     </a:solidFill>
                   </a:tcPr>
                 </a:tc>
-                <a:extLst>
-                  <a:ext uri="{0D108BD9-81ED-4DB2-BD59-A6C34878D82A}">
-                    <a16:rowId xmlns:a16="http://schemas.microsoft.com/office/drawing/2014/main" val="10001"/>
-                  </a:ext>
-                </a:extLst>
               </a:tr>
               <a:tr h="261257">
                 <a:tc>
@@ -9059,11 +8828,6 @@
                     </a:solidFill>
                   </a:tcPr>
                 </a:tc>
-                <a:extLst>
-                  <a:ext uri="{0D108BD9-81ED-4DB2-BD59-A6C34878D82A}">
-                    <a16:rowId xmlns:a16="http://schemas.microsoft.com/office/drawing/2014/main" val="10002"/>
-                  </a:ext>
-                </a:extLst>
               </a:tr>
               <a:tr h="261257">
                 <a:tc>
@@ -9158,11 +8922,6 @@
                     </a:solidFill>
                   </a:tcPr>
                 </a:tc>
-                <a:extLst>
-                  <a:ext uri="{0D108BD9-81ED-4DB2-BD59-A6C34878D82A}">
-                    <a16:rowId xmlns:a16="http://schemas.microsoft.com/office/drawing/2014/main" val="10003"/>
-                  </a:ext>
-                </a:extLst>
               </a:tr>
               <a:tr h="261257">
                 <a:tc>
@@ -9257,11 +9016,6 @@
                     </a:solidFill>
                   </a:tcPr>
                 </a:tc>
-                <a:extLst>
-                  <a:ext uri="{0D108BD9-81ED-4DB2-BD59-A6C34878D82A}">
-                    <a16:rowId xmlns:a16="http://schemas.microsoft.com/office/drawing/2014/main" val="10004"/>
-                  </a:ext>
-                </a:extLst>
               </a:tr>
               <a:tr h="261257">
                 <a:tc>
@@ -9356,11 +9110,6 @@
                     </a:solidFill>
                   </a:tcPr>
                 </a:tc>
-                <a:extLst>
-                  <a:ext uri="{0D108BD9-81ED-4DB2-BD59-A6C34878D82A}">
-                    <a16:rowId xmlns:a16="http://schemas.microsoft.com/office/drawing/2014/main" val="10005"/>
-                  </a:ext>
-                </a:extLst>
               </a:tr>
               <a:tr h="261258">
                 <a:tc>
@@ -9455,11 +9204,6 @@
                     </a:solidFill>
                   </a:tcPr>
                 </a:tc>
-                <a:extLst>
-                  <a:ext uri="{0D108BD9-81ED-4DB2-BD59-A6C34878D82A}">
-                    <a16:rowId xmlns:a16="http://schemas.microsoft.com/office/drawing/2014/main" val="10006"/>
-                  </a:ext>
-                </a:extLst>
               </a:tr>
             </a:tbl>
           </a:graphicData>
@@ -9519,41 +9263,11 @@
                 <a:tableStyleId>{5C22544A-7EE6-4342-B048-85BDC9FD1C3A}</a:tableStyleId>
               </a:tblPr>
               <a:tblGrid>
-                <a:gridCol w="1828800">
-                  <a:extLst>
-                    <a:ext uri="{9D8B030D-6E8A-4147-A177-3AD203B41FA5}">
-                      <a16:colId xmlns:a16="http://schemas.microsoft.com/office/drawing/2014/main" val="20000"/>
-                    </a:ext>
-                  </a:extLst>
-                </a:gridCol>
-                <a:gridCol w="822960">
-                  <a:extLst>
-                    <a:ext uri="{9D8B030D-6E8A-4147-A177-3AD203B41FA5}">
-                      <a16:colId xmlns:a16="http://schemas.microsoft.com/office/drawing/2014/main" val="20001"/>
-                    </a:ext>
-                  </a:extLst>
-                </a:gridCol>
-                <a:gridCol w="548640">
-                  <a:extLst>
-                    <a:ext uri="{9D8B030D-6E8A-4147-A177-3AD203B41FA5}">
-                      <a16:colId xmlns:a16="http://schemas.microsoft.com/office/drawing/2014/main" val="20002"/>
-                    </a:ext>
-                  </a:extLst>
-                </a:gridCol>
-                <a:gridCol w="1280160">
-                  <a:extLst>
-                    <a:ext uri="{9D8B030D-6E8A-4147-A177-3AD203B41FA5}">
-                      <a16:colId xmlns:a16="http://schemas.microsoft.com/office/drawing/2014/main" val="20003"/>
-                    </a:ext>
-                  </a:extLst>
-                </a:gridCol>
-                <a:gridCol w="914400">
-                  <a:extLst>
-                    <a:ext uri="{9D8B030D-6E8A-4147-A177-3AD203B41FA5}">
-                      <a16:colId xmlns:a16="http://schemas.microsoft.com/office/drawing/2014/main" val="20004"/>
-                    </a:ext>
-                  </a:extLst>
-                </a:gridCol>
+                <a:gridCol w="1828800"/>
+                <a:gridCol w="822960"/>
+                <a:gridCol w="548640"/>
+                <a:gridCol w="1280160"/>
+                <a:gridCol w="914400"/>
               </a:tblGrid>
               <a:tr h="215537">
                 <a:tc>
@@ -9671,11 +9385,6 @@
                     </a:solidFill>
                   </a:tcPr>
                 </a:tc>
-                <a:extLst>
-                  <a:ext uri="{0D108BD9-81ED-4DB2-BD59-A6C34878D82A}">
-                    <a16:rowId xmlns:a16="http://schemas.microsoft.com/office/drawing/2014/main" val="10000"/>
-                  </a:ext>
-                </a:extLst>
               </a:tr>
               <a:tr h="215537">
                 <a:tc>
@@ -9793,11 +9502,6 @@
                     </a:solidFill>
                   </a:tcPr>
                 </a:tc>
-                <a:extLst>
-                  <a:ext uri="{0D108BD9-81ED-4DB2-BD59-A6C34878D82A}">
-                    <a16:rowId xmlns:a16="http://schemas.microsoft.com/office/drawing/2014/main" val="10001"/>
-                  </a:ext>
-                </a:extLst>
               </a:tr>
               <a:tr h="215537">
                 <a:tc>
@@ -9915,11 +9619,6 @@
                     </a:solidFill>
                   </a:tcPr>
                 </a:tc>
-                <a:extLst>
-                  <a:ext uri="{0D108BD9-81ED-4DB2-BD59-A6C34878D82A}">
-                    <a16:rowId xmlns:a16="http://schemas.microsoft.com/office/drawing/2014/main" val="10002"/>
-                  </a:ext>
-                </a:extLst>
               </a:tr>
               <a:tr h="215537">
                 <a:tc>
@@ -10037,11 +9736,6 @@
                     </a:solidFill>
                   </a:tcPr>
                 </a:tc>
-                <a:extLst>
-                  <a:ext uri="{0D108BD9-81ED-4DB2-BD59-A6C34878D82A}">
-                    <a16:rowId xmlns:a16="http://schemas.microsoft.com/office/drawing/2014/main" val="10003"/>
-                  </a:ext>
-                </a:extLst>
               </a:tr>
               <a:tr h="215537">
                 <a:tc>
@@ -10159,11 +9853,6 @@
                     </a:solidFill>
                   </a:tcPr>
                 </a:tc>
-                <a:extLst>
-                  <a:ext uri="{0D108BD9-81ED-4DB2-BD59-A6C34878D82A}">
-                    <a16:rowId xmlns:a16="http://schemas.microsoft.com/office/drawing/2014/main" val="10004"/>
-                  </a:ext>
-                </a:extLst>
               </a:tr>
               <a:tr h="215537">
                 <a:tc>
@@ -10281,11 +9970,6 @@
                     </a:solidFill>
                   </a:tcPr>
                 </a:tc>
-                <a:extLst>
-                  <a:ext uri="{0D108BD9-81ED-4DB2-BD59-A6C34878D82A}">
-                    <a16:rowId xmlns:a16="http://schemas.microsoft.com/office/drawing/2014/main" val="10005"/>
-                  </a:ext>
-                </a:extLst>
               </a:tr>
               <a:tr h="215538">
                 <a:tc>
@@ -10403,11 +10087,6 @@
                     </a:solidFill>
                   </a:tcPr>
                 </a:tc>
-                <a:extLst>
-                  <a:ext uri="{0D108BD9-81ED-4DB2-BD59-A6C34878D82A}">
-                    <a16:rowId xmlns:a16="http://schemas.microsoft.com/office/drawing/2014/main" val="10006"/>
-                  </a:ext>
-                </a:extLst>
               </a:tr>
             </a:tbl>
           </a:graphicData>
@@ -10467,41 +10146,11 @@
                 <a:tableStyleId>{5C22544A-7EE6-4342-B048-85BDC9FD1C3A}</a:tableStyleId>
               </a:tblPr>
               <a:tblGrid>
-                <a:gridCol w="1920240">
-                  <a:extLst>
-                    <a:ext uri="{9D8B030D-6E8A-4147-A177-3AD203B41FA5}">
-                      <a16:colId xmlns:a16="http://schemas.microsoft.com/office/drawing/2014/main" val="20000"/>
-                    </a:ext>
-                  </a:extLst>
-                </a:gridCol>
-                <a:gridCol w="822960">
-                  <a:extLst>
-                    <a:ext uri="{9D8B030D-6E8A-4147-A177-3AD203B41FA5}">
-                      <a16:colId xmlns:a16="http://schemas.microsoft.com/office/drawing/2014/main" val="20001"/>
-                    </a:ext>
-                  </a:extLst>
-                </a:gridCol>
-                <a:gridCol w="731520">
-                  <a:extLst>
-                    <a:ext uri="{9D8B030D-6E8A-4147-A177-3AD203B41FA5}">
-                      <a16:colId xmlns:a16="http://schemas.microsoft.com/office/drawing/2014/main" val="20002"/>
-                    </a:ext>
-                  </a:extLst>
-                </a:gridCol>
-                <a:gridCol w="914400">
-                  <a:extLst>
-                    <a:ext uri="{9D8B030D-6E8A-4147-A177-3AD203B41FA5}">
-                      <a16:colId xmlns:a16="http://schemas.microsoft.com/office/drawing/2014/main" val="20003"/>
-                    </a:ext>
-                  </a:extLst>
-                </a:gridCol>
-                <a:gridCol w="914400">
-                  <a:extLst>
-                    <a:ext uri="{9D8B030D-6E8A-4147-A177-3AD203B41FA5}">
-                      <a16:colId xmlns:a16="http://schemas.microsoft.com/office/drawing/2014/main" val="20004"/>
-                    </a:ext>
-                  </a:extLst>
-                </a:gridCol>
+                <a:gridCol w="1920240"/>
+                <a:gridCol w="822960"/>
+                <a:gridCol w="731520"/>
+                <a:gridCol w="914400"/>
+                <a:gridCol w="914400"/>
               </a:tblGrid>
               <a:tr h="215537">
                 <a:tc>
@@ -10619,11 +10268,6 @@
                     </a:solidFill>
                   </a:tcPr>
                 </a:tc>
-                <a:extLst>
-                  <a:ext uri="{0D108BD9-81ED-4DB2-BD59-A6C34878D82A}">
-                    <a16:rowId xmlns:a16="http://schemas.microsoft.com/office/drawing/2014/main" val="10000"/>
-                  </a:ext>
-                </a:extLst>
               </a:tr>
               <a:tr h="215537">
                 <a:tc>
@@ -10741,11 +10385,6 @@
                     </a:solidFill>
                   </a:tcPr>
                 </a:tc>
-                <a:extLst>
-                  <a:ext uri="{0D108BD9-81ED-4DB2-BD59-A6C34878D82A}">
-                    <a16:rowId xmlns:a16="http://schemas.microsoft.com/office/drawing/2014/main" val="10001"/>
-                  </a:ext>
-                </a:extLst>
               </a:tr>
               <a:tr h="215537">
                 <a:tc>
@@ -10863,11 +10502,6 @@
                     </a:solidFill>
                   </a:tcPr>
                 </a:tc>
-                <a:extLst>
-                  <a:ext uri="{0D108BD9-81ED-4DB2-BD59-A6C34878D82A}">
-                    <a16:rowId xmlns:a16="http://schemas.microsoft.com/office/drawing/2014/main" val="10002"/>
-                  </a:ext>
-                </a:extLst>
               </a:tr>
               <a:tr h="215537">
                 <a:tc>
@@ -10985,11 +10619,6 @@
                     </a:solidFill>
                   </a:tcPr>
                 </a:tc>
-                <a:extLst>
-                  <a:ext uri="{0D108BD9-81ED-4DB2-BD59-A6C34878D82A}">
-                    <a16:rowId xmlns:a16="http://schemas.microsoft.com/office/drawing/2014/main" val="10003"/>
-                  </a:ext>
-                </a:extLst>
               </a:tr>
               <a:tr h="215537">
                 <a:tc>
@@ -11107,11 +10736,6 @@
                     </a:solidFill>
                   </a:tcPr>
                 </a:tc>
-                <a:extLst>
-                  <a:ext uri="{0D108BD9-81ED-4DB2-BD59-A6C34878D82A}">
-                    <a16:rowId xmlns:a16="http://schemas.microsoft.com/office/drawing/2014/main" val="10004"/>
-                  </a:ext>
-                </a:extLst>
               </a:tr>
               <a:tr h="215537">
                 <a:tc>
@@ -11229,11 +10853,6 @@
                     </a:solidFill>
                   </a:tcPr>
                 </a:tc>
-                <a:extLst>
-                  <a:ext uri="{0D108BD9-81ED-4DB2-BD59-A6C34878D82A}">
-                    <a16:rowId xmlns:a16="http://schemas.microsoft.com/office/drawing/2014/main" val="10005"/>
-                  </a:ext>
-                </a:extLst>
               </a:tr>
               <a:tr h="215538">
                 <a:tc>
@@ -11351,11 +10970,6 @@
                     </a:solidFill>
                   </a:tcPr>
                 </a:tc>
-                <a:extLst>
-                  <a:ext uri="{0D108BD9-81ED-4DB2-BD59-A6C34878D82A}">
-                    <a16:rowId xmlns:a16="http://schemas.microsoft.com/office/drawing/2014/main" val="10006"/>
-                  </a:ext>
-                </a:extLst>
               </a:tr>
             </a:tbl>
           </a:graphicData>
@@ -11439,7 +11053,7 @@
 </file>
 
 <file path=ppt/slides/slide8.xml><?xml version="1.0" encoding="utf-8"?>
-<p:sld xmlns:a="http://schemas.openxmlformats.org/drawingml/2006/main" xmlns:r="http://schemas.openxmlformats.org/officeDocument/2006/relationships" xmlns:p="http://schemas.openxmlformats.org/presentationml/2006/main">
+<p:sld xmlns:a="http://schemas.openxmlformats.org/drawingml/2006/main" xmlns:p="http://schemas.openxmlformats.org/presentationml/2006/main" xmlns:r="http://schemas.openxmlformats.org/officeDocument/2006/relationships">
   <p:cSld>
     <p:spTree>
       <p:nvGrpSpPr>
@@ -11447,14 +11061,7 @@
         <p:cNvGrpSpPr/>
         <p:nvPr/>
       </p:nvGrpSpPr>
-      <p:grpSpPr>
-        <a:xfrm>
-          <a:off x="0" y="0"/>
-          <a:ext cx="0" cy="0"/>
-          <a:chOff x="0" y="0"/>
-          <a:chExt cx="0" cy="0"/>
-        </a:xfrm>
-      </p:grpSpPr>
+      <p:grpSpPr/>
       <p:sp>
         <p:nvSpPr>
           <p:cNvPr id="2" name="Rectangle 1"/>
@@ -11496,7 +11103,6 @@
           <a:lstStyle/>
           <a:p>
             <a:pPr algn="ctr"/>
-            <a:endParaRPr/>
           </a:p>
         </p:txBody>
       </p:sp>
@@ -11541,7 +11147,6 @@
           <a:lstStyle/>
           <a:p>
             <a:pPr algn="ctr"/>
-            <a:endParaRPr/>
           </a:p>
         </p:txBody>
       </p:sp>
@@ -11632,48 +11237,12 @@
                 <a:tableStyleId>{5C22544A-7EE6-4342-B048-85BDC9FD1C3A}</a:tableStyleId>
               </a:tblPr>
               <a:tblGrid>
-                <a:gridCol w="1798320">
-                  <a:extLst>
-                    <a:ext uri="{9D8B030D-6E8A-4147-A177-3AD203B41FA5}">
-                      <a16:colId xmlns:a16="http://schemas.microsoft.com/office/drawing/2014/main" val="20000"/>
-                    </a:ext>
-                  </a:extLst>
-                </a:gridCol>
-                <a:gridCol w="1798320">
-                  <a:extLst>
-                    <a:ext uri="{9D8B030D-6E8A-4147-A177-3AD203B41FA5}">
-                      <a16:colId xmlns:a16="http://schemas.microsoft.com/office/drawing/2014/main" val="20001"/>
-                    </a:ext>
-                  </a:extLst>
-                </a:gridCol>
-                <a:gridCol w="1798320">
-                  <a:extLst>
-                    <a:ext uri="{9D8B030D-6E8A-4147-A177-3AD203B41FA5}">
-                      <a16:colId xmlns:a16="http://schemas.microsoft.com/office/drawing/2014/main" val="20002"/>
-                    </a:ext>
-                  </a:extLst>
-                </a:gridCol>
-                <a:gridCol w="1798320">
-                  <a:extLst>
-                    <a:ext uri="{9D8B030D-6E8A-4147-A177-3AD203B41FA5}">
-                      <a16:colId xmlns:a16="http://schemas.microsoft.com/office/drawing/2014/main" val="20003"/>
-                    </a:ext>
-                  </a:extLst>
-                </a:gridCol>
-                <a:gridCol w="1798320">
-                  <a:extLst>
-                    <a:ext uri="{9D8B030D-6E8A-4147-A177-3AD203B41FA5}">
-                      <a16:colId xmlns:a16="http://schemas.microsoft.com/office/drawing/2014/main" val="20004"/>
-                    </a:ext>
-                  </a:extLst>
-                </a:gridCol>
-                <a:gridCol w="1798320">
-                  <a:extLst>
-                    <a:ext uri="{9D8B030D-6E8A-4147-A177-3AD203B41FA5}">
-                      <a16:colId xmlns:a16="http://schemas.microsoft.com/office/drawing/2014/main" val="20005"/>
-                    </a:ext>
-                  </a:extLst>
-                </a:gridCol>
+                <a:gridCol w="1798320"/>
+                <a:gridCol w="1798320"/>
+                <a:gridCol w="1798320"/>
+                <a:gridCol w="1798320"/>
+                <a:gridCol w="1798320"/>
+                <a:gridCol w="1798320"/>
               </a:tblGrid>
               <a:tr h="444137">
                 <a:tc>
@@ -11814,11 +11383,6 @@
                     </a:solidFill>
                   </a:tcPr>
                 </a:tc>
-                <a:extLst>
-                  <a:ext uri="{0D108BD9-81ED-4DB2-BD59-A6C34878D82A}">
-                    <a16:rowId xmlns:a16="http://schemas.microsoft.com/office/drawing/2014/main" val="10000"/>
-                  </a:ext>
-                </a:extLst>
               </a:tr>
               <a:tr h="444137">
                 <a:tc>
@@ -11959,11 +11523,6 @@
                     </a:solidFill>
                   </a:tcPr>
                 </a:tc>
-                <a:extLst>
-                  <a:ext uri="{0D108BD9-81ED-4DB2-BD59-A6C34878D82A}">
-                    <a16:rowId xmlns:a16="http://schemas.microsoft.com/office/drawing/2014/main" val="10001"/>
-                  </a:ext>
-                </a:extLst>
               </a:tr>
               <a:tr h="444137">
                 <a:tc>
@@ -12104,11 +11663,6 @@
                     </a:solidFill>
                   </a:tcPr>
                 </a:tc>
-                <a:extLst>
-                  <a:ext uri="{0D108BD9-81ED-4DB2-BD59-A6C34878D82A}">
-                    <a16:rowId xmlns:a16="http://schemas.microsoft.com/office/drawing/2014/main" val="10002"/>
-                  </a:ext>
-                </a:extLst>
               </a:tr>
               <a:tr h="444137">
                 <a:tc>
@@ -12249,11 +11803,6 @@
                     </a:solidFill>
                   </a:tcPr>
                 </a:tc>
-                <a:extLst>
-                  <a:ext uri="{0D108BD9-81ED-4DB2-BD59-A6C34878D82A}">
-                    <a16:rowId xmlns:a16="http://schemas.microsoft.com/office/drawing/2014/main" val="10003"/>
-                  </a:ext>
-                </a:extLst>
               </a:tr>
               <a:tr h="444137">
                 <a:tc>
@@ -12394,11 +11943,6 @@
                     </a:solidFill>
                   </a:tcPr>
                 </a:tc>
-                <a:extLst>
-                  <a:ext uri="{0D108BD9-81ED-4DB2-BD59-A6C34878D82A}">
-                    <a16:rowId xmlns:a16="http://schemas.microsoft.com/office/drawing/2014/main" val="10004"/>
-                  </a:ext>
-                </a:extLst>
               </a:tr>
               <a:tr h="444137">
                 <a:tc>
@@ -12539,11 +12083,6 @@
                     </a:solidFill>
                   </a:tcPr>
                 </a:tc>
-                <a:extLst>
-                  <a:ext uri="{0D108BD9-81ED-4DB2-BD59-A6C34878D82A}">
-                    <a16:rowId xmlns:a16="http://schemas.microsoft.com/office/drawing/2014/main" val="10005"/>
-                  </a:ext>
-                </a:extLst>
               </a:tr>
               <a:tr h="444138">
                 <a:tc>
@@ -12684,11 +12223,6 @@
                     </a:solidFill>
                   </a:tcPr>
                 </a:tc>
-                <a:extLst>
-                  <a:ext uri="{0D108BD9-81ED-4DB2-BD59-A6C34878D82A}">
-                    <a16:rowId xmlns:a16="http://schemas.microsoft.com/office/drawing/2014/main" val="10006"/>
-                  </a:ext>
-                </a:extLst>
               </a:tr>
             </a:tbl>
           </a:graphicData>
@@ -12772,7 +12306,7 @@
 </file>
 
 <file path=ppt/slides/slide9.xml><?xml version="1.0" encoding="utf-8"?>
-<p:sld xmlns:a="http://schemas.openxmlformats.org/drawingml/2006/main" xmlns:r="http://schemas.openxmlformats.org/officeDocument/2006/relationships" xmlns:p="http://schemas.openxmlformats.org/presentationml/2006/main">
+<p:sld xmlns:a="http://schemas.openxmlformats.org/drawingml/2006/main" xmlns:p="http://schemas.openxmlformats.org/presentationml/2006/main" xmlns:r="http://schemas.openxmlformats.org/officeDocument/2006/relationships">
   <p:cSld>
     <p:spTree>
       <p:nvGrpSpPr>
@@ -12780,14 +12314,7 @@
         <p:cNvGrpSpPr/>
         <p:nvPr/>
       </p:nvGrpSpPr>
-      <p:grpSpPr>
-        <a:xfrm>
-          <a:off x="0" y="0"/>
-          <a:ext cx="0" cy="0"/>
-          <a:chOff x="0" y="0"/>
-          <a:chExt cx="0" cy="0"/>
-        </a:xfrm>
-      </p:grpSpPr>
+      <p:grpSpPr/>
       <p:sp>
         <p:nvSpPr>
           <p:cNvPr id="2" name="Rectangle 1"/>
@@ -12829,7 +12356,6 @@
           <a:lstStyle/>
           <a:p>
             <a:pPr algn="ctr"/>
-            <a:endParaRPr/>
           </a:p>
         </p:txBody>
       </p:sp>
@@ -12874,7 +12400,6 @@
           <a:lstStyle/>
           <a:p>
             <a:pPr algn="ctr"/>
-            <a:endParaRPr/>
           </a:p>
         </p:txBody>
       </p:sp>

</xml_diff>

<commit_message>
Review_Presentation.pptx: flatten nested parens + NMQ 4-area disclosure
Slide 10 Posture recommendation: flatten the doubly-nested "(84% at RULA
grand score 5+ (action level 3 or 4))" to a comma-joined single paren.

Slide 4 Q19: name the four rider-relevant NMQ 7-day areas (neck, lower
back, wrist/hands, knees) so the deck matches the report's disclosure
that the standard 9-region NMQ is truncated to 4 areas.

Co-Authored-By: Claude Opus 4.7 <noreply@anthropic.com>
</commit_message>
<xml_diff>
--- a/deck/Review_Presentation.pptx
+++ b/deck/Review_Presentation.pptx
@@ -3952,7 +3952,7 @@
                 </a:solidFill>
                 <a:latin typeface="Calibri"/>
               </a:rPr>
-              <a:t>•   Posture training and equipment review (84% at RULA grand score 5+ (action level 3 or 4)).</a:t>
+              <a:t>•   Posture training and equipment review (84% at RULA grand score 5+, action level 3 or 4).</a:t>
             </a:r>
           </a:p>
           <a:p>
@@ -5397,7 +5397,7 @@
                 </a:solidFill>
                 <a:latin typeface="Calibri"/>
               </a:rPr>
-              <a:t>–   </a:t>
+              <a:t>–   Q19: 7-day discomfort (neck, lower back, wrist/hands, knees)</a:t>
             </a:r>
             <a:r>
               <a:rPr sz="1200" b="0" i="0">
@@ -5406,7 +5406,7 @@
                 </a:solidFill>
                 <a:latin typeface="Calibri"/>
               </a:rPr>
-              <a:t>Q19: 7-day discomfort (4 areas)</a:t>
+              <a:t/>
             </a:r>
           </a:p>
           <a:p>

</xml_diff>